<commit_message>
fix comparison with anditi presentation part
</commit_message>
<xml_diff>
--- a/presentations/27.2/School mapping in ESRI imagery.pptx
+++ b/presentations/27.2/School mapping in ESRI imagery.pptx
@@ -6800,11 +6800,11 @@
             <a:pPr lvl="1"/>
             <a:r>
               <a:rPr lang="en-US" sz="2400" dirty="0"/>
-              <a:t>Found 839/946 (</a:t>
+              <a:t>Found 936/946 (</a:t>
             </a:r>
             <a:r>
               <a:rPr lang="en-US" sz="2400" b="1" dirty="0"/>
-              <a:t>88.69%</a:t>
+              <a:t>98.94%</a:t>
             </a:r>
             <a:r>
               <a:rPr lang="en-US" sz="2400" dirty="0"/>
@@ -6831,7 +6831,7 @@
             <a:pPr lvl="1"/>
             <a:r>
               <a:rPr lang="en-US" sz="2400" dirty="0"/>
-              <a:t>Recall: 88.69%</a:t>
+              <a:t>Recall: 98.94%</a:t>
             </a:r>
           </a:p>
           <a:p>
@@ -6842,11 +6842,11 @@
             <a:pPr lvl="1"/>
             <a:r>
               <a:rPr lang="en-US" sz="2400" dirty="0"/>
-              <a:t>107 not detected schools (</a:t>
+              <a:t>10 not detected schools (</a:t>
             </a:r>
             <a:r>
               <a:rPr lang="en-US" sz="2400" b="1" dirty="0"/>
-              <a:t>11.31%</a:t>
+              <a:t>1.06%</a:t>
             </a:r>
             <a:r>
               <a:rPr lang="en-US" sz="2400" dirty="0"/>

</xml_diff>

<commit_message>
add wide recall to presentation
</commit_message>
<xml_diff>
--- a/presentations/27.2/School mapping in ESRI imagery.pptx
+++ b/presentations/27.2/School mapping in ESRI imagery.pptx
@@ -5,7 +5,7 @@
     <p:sldMasterId id="2147483684" r:id="rId1"/>
   </p:sldMasterIdLst>
   <p:notesMasterIdLst>
-    <p:notesMasterId r:id="rId19"/>
+    <p:notesMasterId r:id="rId20"/>
   </p:notesMasterIdLst>
   <p:sldIdLst>
     <p:sldId id="256" r:id="rId2"/>
@@ -23,8 +23,9 @@
     <p:sldId id="321" r:id="rId14"/>
     <p:sldId id="298" r:id="rId15"/>
     <p:sldId id="302" r:id="rId16"/>
-    <p:sldId id="322" r:id="rId17"/>
-    <p:sldId id="315" r:id="rId18"/>
+    <p:sldId id="323" r:id="rId17"/>
+    <p:sldId id="322" r:id="rId18"/>
+    <p:sldId id="315" r:id="rId19"/>
   </p:sldIdLst>
   <p:sldSz cx="12192000" cy="6858000"/>
   <p:notesSz cx="6858000" cy="9144000"/>
@@ -6603,15 +6604,7 @@
             </a:r>
             <a:r>
               <a:rPr lang="en-US" sz="2400" b="1" dirty="0"/>
-              <a:t>number of detected </a:t>
-            </a:r>
-            <a:r>
-              <a:rPr lang="en-US" sz="2400" b="1" dirty="0" err="1"/>
-              <a:t>Anditi</a:t>
-            </a:r>
-            <a:r>
-              <a:rPr lang="en-US" sz="2400" b="1" dirty="0"/>
-              <a:t> schools (train data)</a:t>
+              <a:t>number of detected schools</a:t>
             </a:r>
           </a:p>
           <a:p>
@@ -6727,7 +6720,12 @@
             <p:ph type="title"/>
           </p:nvPr>
         </p:nvSpPr>
-        <p:spPr/>
+        <p:spPr>
+          <a:xfrm>
+            <a:off x="1097280" y="286603"/>
+            <a:ext cx="10616738" cy="1450757"/>
+          </a:xfrm>
+        </p:spPr>
         <p:txBody>
           <a:bodyPr/>
           <a:lstStyle/>
@@ -6735,6 +6733,14 @@
             <a:r>
               <a:rPr lang="hr-HR" dirty="0"/>
               <a:t>Dense inference</a:t>
+            </a:r>
+            <a:r>
+              <a:rPr lang="en-US" dirty="0"/>
+              <a:t>, </a:t>
+            </a:r>
+            <a:r>
+              <a:rPr lang="en-US" dirty="0" err="1"/>
+              <a:t>Anditi</a:t>
             </a:r>
             <a:r>
               <a:rPr lang="en-US" dirty="0"/>
@@ -6914,6 +6920,222 @@
 </file>
 
 <file path=ppt/slides/slide16.xml><?xml version="1.0" encoding="utf-8"?>
+<p:sld xmlns:a="http://schemas.openxmlformats.org/drawingml/2006/main" xmlns:r="http://schemas.openxmlformats.org/officeDocument/2006/relationships" xmlns:p="http://schemas.openxmlformats.org/presentationml/2006/main">
+  <p:cSld>
+    <p:spTree>
+      <p:nvGrpSpPr>
+        <p:cNvPr id="1" name="">
+          <a:extLst>
+            <a:ext uri="{FF2B5EF4-FFF2-40B4-BE49-F238E27FC236}">
+              <a16:creationId xmlns:a16="http://schemas.microsoft.com/office/drawing/2014/main" id="{6D202C21-7E56-4F69-015C-2327638DFEF4}"/>
+            </a:ext>
+          </a:extLst>
+        </p:cNvPr>
+        <p:cNvGrpSpPr/>
+        <p:nvPr/>
+      </p:nvGrpSpPr>
+      <p:grpSpPr>
+        <a:xfrm>
+          <a:off x="0" y="0"/>
+          <a:ext cx="0" cy="0"/>
+          <a:chOff x="0" y="0"/>
+          <a:chExt cx="0" cy="0"/>
+        </a:xfrm>
+      </p:grpSpPr>
+      <p:sp>
+        <p:nvSpPr>
+          <p:cNvPr id="2" name="Title 1">
+            <a:extLst>
+              <a:ext uri="{FF2B5EF4-FFF2-40B4-BE49-F238E27FC236}">
+                <a16:creationId xmlns:a16="http://schemas.microsoft.com/office/drawing/2014/main" id="{0ECFFA1E-E1B5-EC4E-A83A-2132B53555BD}"/>
+              </a:ext>
+            </a:extLst>
+          </p:cNvPr>
+          <p:cNvSpPr>
+            <a:spLocks noGrp="1"/>
+          </p:cNvSpPr>
+          <p:nvPr>
+            <p:ph type="title"/>
+          </p:nvPr>
+        </p:nvSpPr>
+        <p:spPr>
+          <a:xfrm>
+            <a:off x="1097279" y="286603"/>
+            <a:ext cx="10457411" cy="1450757"/>
+          </a:xfrm>
+        </p:spPr>
+        <p:txBody>
+          <a:bodyPr/>
+          <a:lstStyle/>
+          <a:p>
+            <a:r>
+              <a:rPr lang="hr-HR" dirty="0"/>
+              <a:t>Dense inference</a:t>
+            </a:r>
+            <a:r>
+              <a:rPr lang="en-US" dirty="0"/>
+              <a:t>, wide results (after NMS)</a:t>
+            </a:r>
+            <a:endParaRPr lang="hr-HR" dirty="0"/>
+          </a:p>
+        </p:txBody>
+      </p:sp>
+      <p:sp>
+        <p:nvSpPr>
+          <p:cNvPr id="3" name="Content Placeholder 2">
+            <a:extLst>
+              <a:ext uri="{FF2B5EF4-FFF2-40B4-BE49-F238E27FC236}">
+                <a16:creationId xmlns:a16="http://schemas.microsoft.com/office/drawing/2014/main" id="{48E00BB3-59DC-26AE-DF5A-EC1A2B056648}"/>
+              </a:ext>
+            </a:extLst>
+          </p:cNvPr>
+          <p:cNvSpPr>
+            <a:spLocks noGrp="1"/>
+          </p:cNvSpPr>
+          <p:nvPr>
+            <p:ph idx="1"/>
+          </p:nvPr>
+        </p:nvSpPr>
+        <p:spPr>
+          <a:xfrm>
+            <a:off x="1097279" y="1845733"/>
+            <a:ext cx="10772503" cy="4441855"/>
+          </a:xfrm>
+        </p:spPr>
+        <p:txBody>
+          <a:bodyPr>
+            <a:normAutofit/>
+          </a:bodyPr>
+          <a:lstStyle/>
+          <a:p>
+            <a:pPr lvl="1"/>
+            <a:r>
+              <a:rPr lang="hr-HR" sz="2400" dirty="0"/>
+              <a:t>Check performance on </a:t>
+            </a:r>
+            <a:r>
+              <a:rPr lang="en-US" sz="2400" b="1" dirty="0"/>
+              <a:t>wide</a:t>
+            </a:r>
+            <a:r>
+              <a:rPr lang="hr-HR" sz="2400" b="1" dirty="0"/>
+              <a:t> data</a:t>
+            </a:r>
+            <a:r>
+              <a:rPr lang="en-US" sz="2400" b="1" dirty="0"/>
+              <a:t>set</a:t>
+            </a:r>
+          </a:p>
+          <a:p>
+            <a:pPr marL="201168" lvl="1" indent="0">
+              <a:buNone/>
+            </a:pPr>
+            <a:endParaRPr lang="hr-HR" sz="2400" dirty="0"/>
+          </a:p>
+          <a:p>
+            <a:pPr lvl="1"/>
+            <a:r>
+              <a:rPr lang="en-US" sz="2400" dirty="0"/>
+              <a:t>Found 88/93 (</a:t>
+            </a:r>
+            <a:r>
+              <a:rPr lang="en-US" sz="2400" b="1" dirty="0"/>
+              <a:t>94.62%</a:t>
+            </a:r>
+            <a:r>
+              <a:rPr lang="en-US" sz="2400" dirty="0"/>
+              <a:t>)</a:t>
+            </a:r>
+            <a:r>
+              <a:rPr lang="en-US" sz="2400" b="1" dirty="0"/>
+              <a:t> </a:t>
+            </a:r>
+            <a:r>
+              <a:rPr lang="en-US" sz="2400" dirty="0"/>
+              <a:t>schools</a:t>
+            </a:r>
+          </a:p>
+          <a:p>
+            <a:pPr lvl="1"/>
+            <a:endParaRPr lang="en-US" sz="2400" dirty="0"/>
+          </a:p>
+          <a:p>
+            <a:pPr lvl="1"/>
+            <a:r>
+              <a:rPr lang="en-US" sz="2400" dirty="0"/>
+              <a:t>Recall: 94.62%</a:t>
+            </a:r>
+          </a:p>
+          <a:p>
+            <a:pPr lvl="1"/>
+            <a:endParaRPr lang="en-US" sz="2400" dirty="0"/>
+          </a:p>
+          <a:p>
+            <a:pPr lvl="1"/>
+            <a:r>
+              <a:rPr lang="en-US" sz="2400" dirty="0"/>
+              <a:t>5 not detected schools (</a:t>
+            </a:r>
+            <a:r>
+              <a:rPr lang="en-US" sz="2400" b="1" dirty="0"/>
+              <a:t>5.38%</a:t>
+            </a:r>
+            <a:r>
+              <a:rPr lang="en-US" sz="2400" dirty="0"/>
+              <a:t>)</a:t>
+            </a:r>
+          </a:p>
+          <a:p>
+            <a:pPr marL="201168" lvl="1" indent="0">
+              <a:buNone/>
+            </a:pPr>
+            <a:endParaRPr lang="en-US" sz="2400" dirty="0"/>
+          </a:p>
+        </p:txBody>
+      </p:sp>
+      <p:sp>
+        <p:nvSpPr>
+          <p:cNvPr id="4" name="Slide Number Placeholder 3">
+            <a:extLst>
+              <a:ext uri="{FF2B5EF4-FFF2-40B4-BE49-F238E27FC236}">
+                <a16:creationId xmlns:a16="http://schemas.microsoft.com/office/drawing/2014/main" id="{1A201542-DA6E-1C0A-4513-CDA6DC54E09F}"/>
+              </a:ext>
+            </a:extLst>
+          </p:cNvPr>
+          <p:cNvSpPr>
+            <a:spLocks noGrp="1"/>
+          </p:cNvSpPr>
+          <p:nvPr>
+            <p:ph type="sldNum" sz="quarter" idx="12"/>
+          </p:nvPr>
+        </p:nvSpPr>
+        <p:spPr/>
+        <p:txBody>
+          <a:bodyPr/>
+          <a:lstStyle/>
+          <a:p>
+            <a:fld id="{5434875C-B374-4DCB-B0EF-B862E54336C8}" type="slidenum">
+              <a:rPr lang="hr-HR" smtClean="0"/>
+              <a:t>16</a:t>
+            </a:fld>
+            <a:endParaRPr lang="hr-HR"/>
+          </a:p>
+        </p:txBody>
+      </p:sp>
+    </p:spTree>
+    <p:extLst>
+      <p:ext uri="{BB962C8B-B14F-4D97-AF65-F5344CB8AC3E}">
+        <p14:creationId xmlns:p14="http://schemas.microsoft.com/office/powerpoint/2010/main" val="719781610"/>
+      </p:ext>
+    </p:extLst>
+  </p:cSld>
+  <p:clrMapOvr>
+    <a:masterClrMapping/>
+  </p:clrMapOvr>
+</p:sld>
+</file>
+
+<file path=ppt/slides/slide17.xml><?xml version="1.0" encoding="utf-8"?>
 <p:sld xmlns:a="http://schemas.openxmlformats.org/drawingml/2006/main" xmlns:r="http://schemas.openxmlformats.org/officeDocument/2006/relationships" xmlns:p="http://schemas.openxmlformats.org/presentationml/2006/main">
   <p:cSld>
     <p:spTree>
@@ -6988,7 +7210,7 @@
           <a:p>
             <a:fld id="{5434875C-B374-4DCB-B0EF-B862E54336C8}" type="slidenum">
               <a:rPr lang="hr-HR" smtClean="0"/>
-              <a:t>16</a:t>
+              <a:t>17</a:t>
             </a:fld>
             <a:endParaRPr lang="hr-HR"/>
           </a:p>
@@ -7484,7 +7706,7 @@
 </p:sld>
 </file>
 
-<file path=ppt/slides/slide17.xml><?xml version="1.0" encoding="utf-8"?>
+<file path=ppt/slides/slide18.xml><?xml version="1.0" encoding="utf-8"?>
 <p:sld xmlns:a="http://schemas.openxmlformats.org/drawingml/2006/main" xmlns:r="http://schemas.openxmlformats.org/officeDocument/2006/relationships" xmlns:p="http://schemas.openxmlformats.org/presentationml/2006/main">
   <p:cSld>
     <p:spTree>
@@ -7647,7 +7869,7 @@
           <a:p>
             <a:fld id="{5434875C-B374-4DCB-B0EF-B862E54336C8}" type="slidenum">
               <a:rPr lang="hr-HR" smtClean="0"/>
-              <a:t>17</a:t>
+              <a:t>18</a:t>
             </a:fld>
             <a:endParaRPr lang="hr-HR"/>
           </a:p>

</xml_diff>